<commit_message>
Remove customer-specific info from architecture diagram
Co-Authored-By: Claude Opus 4.6 <noreply@anthropic.com>
</commit_message>
<xml_diff>
--- a/docs/ClaudeCodeOnBedrock_Architecture.pptx
+++ b/docs/ClaudeCodeOnBedrock_Architecture.pptx
@@ -745,7 +745,7 @@
                 <a:latin typeface="Arial" panose="020B0604020202020204" pitchFamily="34" charset="0"/>
                 <a:cs typeface="Arial" panose="020B0604020202020204" pitchFamily="34" charset="0"/>
               </a:rPr>
-              <a:t>카카오 사용자</a:t>
+              <a:t>사용자</a:t>
             </a:r>
             <a:endParaRPr lang="en-US" sz="1200" dirty="0">
               <a:solidFill>
@@ -1749,7 +1749,7 @@
                   <a:latin typeface="Arial" panose="020B0604020202020204" pitchFamily="34" charset="0"/>
                   <a:cs typeface="Arial" panose="020B0604020202020204" pitchFamily="34" charset="0"/>
                 </a:rPr>
-                <a:t>kakao</a:t>
+                <a:t>On-premise</a:t>
               </a:r>
             </a:p>
           </p:txBody>

</xml_diff>